<commit_message>
refactor: reescrever hard-code MLP em estilo manual e harmonizar artefatos
Substitui a classe HardCodedMLP por funcoes procedurais (treinar/prever/salvar_modelo) com comentarios passo a passo, mantendo os mesmos hiperparametros e resultados. Corrige a velocidade do sklearn de ~6,7x para ~3x (11,3s vs 3,8s) no slide 8 e harmoniza numeros nos guias, docs e vault Obsidian.
</commit_message>
<xml_diff>
--- a/report/apresentacao.pptx
+++ b/report/apresentacao.pptx
@@ -3514,7 +3514,7 @@
                 <a:ea typeface="Segoe UI" pitchFamily="34" charset="-122"/>
                 <a:cs typeface="Segoe UI" pitchFamily="34" charset="-120"/>
               </a:rPr>
-              <a:t>4.205 </a:t>
+              <a:t xml:space="preserve">4.205 </a:t>
             </a:r>
             <a:r>
               <a:rPr lang="en-US" sz="1150" dirty="0">
@@ -3525,7 +3525,7 @@
                 <a:ea typeface="Segoe UI" pitchFamily="34" charset="-122"/>
                 <a:cs typeface="Segoe UI" pitchFamily="34" charset="-120"/>
               </a:rPr>
-              <a:t>clipes   ·   </a:t>
+              <a:t xml:space="preserve">clipes   ·   </a:t>
             </a:r>
             <a:r>
               <a:rPr lang="en-US" sz="1150" b="1" dirty="0">
@@ -3536,7 +3536,7 @@
                 <a:ea typeface="Segoe UI" pitchFamily="34" charset="-122"/>
                 <a:cs typeface="Segoe UI" pitchFamily="34" charset="-120"/>
               </a:rPr>
-              <a:t>96 </a:t>
+              <a:t xml:space="preserve">96 </a:t>
             </a:r>
             <a:r>
               <a:rPr lang="en-US" sz="1150" dirty="0">
@@ -3547,7 +3547,7 @@
                 <a:ea typeface="Segoe UI" pitchFamily="34" charset="-122"/>
                 <a:cs typeface="Segoe UI" pitchFamily="34" charset="-120"/>
               </a:rPr>
-              <a:t>features   ·   </a:t>
+              <a:t xml:space="preserve">features   ·   </a:t>
             </a:r>
             <a:r>
               <a:rPr lang="en-US" sz="1150" b="1" dirty="0">
@@ -3558,7 +3558,7 @@
                 <a:ea typeface="Segoe UI" pitchFamily="34" charset="-122"/>
                 <a:cs typeface="Segoe UI" pitchFamily="34" charset="-120"/>
               </a:rPr>
-              <a:t>97,98% </a:t>
+              <a:t xml:space="preserve">97,98% </a:t>
             </a:r>
             <a:r>
               <a:rPr lang="en-US" sz="1150" dirty="0">
@@ -9445,7 +9445,7 @@
                 <a:ea typeface="Segoe UI" pitchFamily="34" charset="-122"/>
                 <a:cs typeface="Segoe UI" pitchFamily="34" charset="-120"/>
               </a:rPr>
-              <a:t>4 modelos de </a:t>
+              <a:t xml:space="preserve">4 modelos de </a:t>
             </a:r>
             <a:r>
               <a:rPr lang="en-US" sz="1150" dirty="0" err="1">
@@ -9467,7 +9467,7 @@
                 <a:ea typeface="Segoe UI" pitchFamily="34" charset="-122"/>
                 <a:cs typeface="Segoe UI" pitchFamily="34" charset="-120"/>
               </a:rPr>
-              <a:t> </a:t>
+              <a:t xml:space="preserve"> </a:t>
             </a:r>
           </a:p>
           <a:p>
@@ -9487,7 +9487,7 @@
                 <a:ea typeface="Segoe UI" pitchFamily="34" charset="-122"/>
                 <a:cs typeface="Segoe UI" pitchFamily="34" charset="-120"/>
               </a:rPr>
-              <a:t>Audios de 10 </a:t>
+              <a:t xml:space="preserve">Audios de 10 </a:t>
             </a:r>
             <a:r>
               <a:rPr lang="en-US" sz="1150" dirty="0" err="1">
@@ -9537,7 +9537,7 @@
                 <a:ea typeface="Segoe UI" pitchFamily="34" charset="-122"/>
                 <a:cs typeface="Segoe UI" pitchFamily="34" charset="-120"/>
               </a:rPr>
-              <a:t> real de </a:t>
+              <a:t xml:space="preserve"> real de </a:t>
             </a:r>
             <a:r>
               <a:rPr lang="en-US" sz="1150" dirty="0" err="1">
@@ -11859,7 +11859,7 @@
                 <a:ea typeface="Segoe UI" pitchFamily="34" charset="-122"/>
                 <a:cs typeface="Segoe UI" pitchFamily="34" charset="-120"/>
               </a:rPr>
-              <a:t>treino &amp; </a:t>
+              <a:t xml:space="preserve">treino &amp; </a:t>
             </a:r>
             <a:r>
               <a:rPr lang="en-US" sz="850" dirty="0" err="1">
@@ -16895,7 +16895,7 @@
                 <a:ea typeface="Segoe UI" pitchFamily="34" charset="-122"/>
                 <a:cs typeface="Segoe UI" pitchFamily="34" charset="-120"/>
               </a:rPr>
-              <a:t>Código C otimizado (~6,7× mais rápido)</a:t>
+              <a:t>Código C otimizado (~3× mais rápido)</a:t>
             </a:r>
             <a:endParaRPr lang="en-US" sz="1150" dirty="0"/>
           </a:p>
@@ -18880,7 +18880,7 @@
                 <a:ea typeface="Segoe UI" pitchFamily="34" charset="-122"/>
                 <a:cs typeface="Segoe UI" pitchFamily="34" charset="-120"/>
               </a:rPr>
-              <a:t>Matriz de confusão </a:t>
+              <a:t xml:space="preserve">Matriz de confusão </a:t>
             </a:r>
             <a:r>
               <a:rPr lang="en-US" sz="1050" dirty="0">

</xml_diff>

<commit_message>
fix(report): update training epochs and timing details in project explanation
</commit_message>
<xml_diff>
--- a/report/apresentacao.pptx
+++ b/report/apresentacao.pptx
@@ -3514,7 +3514,7 @@
                 <a:ea typeface="Segoe UI" pitchFamily="34" charset="-122"/>
                 <a:cs typeface="Segoe UI" pitchFamily="34" charset="-120"/>
               </a:rPr>
-              <a:t xml:space="preserve">4.205 </a:t>
+              <a:t>4.205 </a:t>
             </a:r>
             <a:r>
               <a:rPr lang="en-US" sz="1150" dirty="0">
@@ -3525,7 +3525,7 @@
                 <a:ea typeface="Segoe UI" pitchFamily="34" charset="-122"/>
                 <a:cs typeface="Segoe UI" pitchFamily="34" charset="-120"/>
               </a:rPr>
-              <a:t xml:space="preserve">clipes   ·   </a:t>
+              <a:t>clipes   ·   </a:t>
             </a:r>
             <a:r>
               <a:rPr lang="en-US" sz="1150" b="1" dirty="0">
@@ -3536,7 +3536,7 @@
                 <a:ea typeface="Segoe UI" pitchFamily="34" charset="-122"/>
                 <a:cs typeface="Segoe UI" pitchFamily="34" charset="-120"/>
               </a:rPr>
-              <a:t xml:space="preserve">96 </a:t>
+              <a:t>96 </a:t>
             </a:r>
             <a:r>
               <a:rPr lang="en-US" sz="1150" dirty="0">
@@ -3547,7 +3547,7 @@
                 <a:ea typeface="Segoe UI" pitchFamily="34" charset="-122"/>
                 <a:cs typeface="Segoe UI" pitchFamily="34" charset="-120"/>
               </a:rPr>
-              <a:t xml:space="preserve">features   ·   </a:t>
+              <a:t>features   ·   </a:t>
             </a:r>
             <a:r>
               <a:rPr lang="en-US" sz="1150" b="1" dirty="0">
@@ -3558,7 +3558,7 @@
                 <a:ea typeface="Segoe UI" pitchFamily="34" charset="-122"/>
                 <a:cs typeface="Segoe UI" pitchFamily="34" charset="-120"/>
               </a:rPr>
-              <a:t xml:space="preserve">97,98% </a:t>
+              <a:t>97,98% </a:t>
             </a:r>
             <a:r>
               <a:rPr lang="en-US" sz="1150" dirty="0">
@@ -9445,7 +9445,7 @@
                 <a:ea typeface="Segoe UI" pitchFamily="34" charset="-122"/>
                 <a:cs typeface="Segoe UI" pitchFamily="34" charset="-120"/>
               </a:rPr>
-              <a:t xml:space="preserve">4 modelos de </a:t>
+              <a:t>4 modelos de </a:t>
             </a:r>
             <a:r>
               <a:rPr lang="en-US" sz="1150" dirty="0" err="1">
@@ -9467,7 +9467,7 @@
                 <a:ea typeface="Segoe UI" pitchFamily="34" charset="-122"/>
                 <a:cs typeface="Segoe UI" pitchFamily="34" charset="-120"/>
               </a:rPr>
-              <a:t xml:space="preserve"> </a:t>
+              <a:t> </a:t>
             </a:r>
           </a:p>
           <a:p>
@@ -9487,7 +9487,7 @@
                 <a:ea typeface="Segoe UI" pitchFamily="34" charset="-122"/>
                 <a:cs typeface="Segoe UI" pitchFamily="34" charset="-120"/>
               </a:rPr>
-              <a:t xml:space="preserve">Audios de 10 </a:t>
+              <a:t>Audios de 10 </a:t>
             </a:r>
             <a:r>
               <a:rPr lang="en-US" sz="1150" dirty="0" err="1">
@@ -9537,7 +9537,7 @@
                 <a:ea typeface="Segoe UI" pitchFamily="34" charset="-122"/>
                 <a:cs typeface="Segoe UI" pitchFamily="34" charset="-120"/>
               </a:rPr>
-              <a:t xml:space="preserve"> real de </a:t>
+              <a:t> real de </a:t>
             </a:r>
             <a:r>
               <a:rPr lang="en-US" sz="1150" dirty="0" err="1">
@@ -11859,7 +11859,7 @@
                 <a:ea typeface="Segoe UI" pitchFamily="34" charset="-122"/>
                 <a:cs typeface="Segoe UI" pitchFamily="34" charset="-120"/>
               </a:rPr>
-              <a:t xml:space="preserve">treino &amp; </a:t>
+              <a:t>treino &amp; </a:t>
             </a:r>
             <a:r>
               <a:rPr lang="en-US" sz="850" dirty="0" err="1">
@@ -16621,7 +16621,7 @@
               <a:buChar char="•"/>
             </a:pPr>
             <a:r>
-              <a:rPr lang="en-US" sz="1150" dirty="0">
+              <a:rPr lang="en-US" sz="1150">
                 <a:solidFill>
                   <a:srgbClr val="A8B8D9"/>
                 </a:solidFill>
@@ -16629,7 +16629,7 @@
                 <a:ea typeface="Segoe UI" pitchFamily="34" charset="-122"/>
                 <a:cs typeface="Segoe UI" pitchFamily="34" charset="-120"/>
               </a:rPr>
-              <a:t>Binary cross-entropy · 300 épocas</a:t>
+              <a:t>Binary cross-entropy</a:t>
             </a:r>
             <a:endParaRPr lang="en-US" sz="1150" dirty="0"/>
           </a:p>
@@ -17725,7 +17725,7 @@
         </p:nvGraphicFramePr>
         <p:xfrm>
           <a:off x="777240" y="3035808"/>
-          <a:ext cx="4297680" cy="914400"/>
+          <a:ext cx="4297680" cy="1371600"/>
         </p:xfrm>
         <a:graphic>
           <a:graphicData uri="http://schemas.openxmlformats.org/drawingml/2006/table">
@@ -18880,7 +18880,7 @@
                 <a:ea typeface="Segoe UI" pitchFamily="34" charset="-122"/>
                 <a:cs typeface="Segoe UI" pitchFamily="34" charset="-120"/>
               </a:rPr>
-              <a:t xml:space="preserve">Matriz de confusão </a:t>
+              <a:t>Matriz de confusão </a:t>
             </a:r>
             <a:r>
               <a:rPr lang="en-US" sz="1050" dirty="0">

</xml_diff>

<commit_message>
feat(report): add backup presentation file
</commit_message>
<xml_diff>
--- a/report/apresentacao.pptx
+++ b/report/apresentacao.pptx
@@ -17725,7 +17725,7 @@
         </p:nvGraphicFramePr>
         <p:xfrm>
           <a:off x="777240" y="3035808"/>
-          <a:ext cx="4297680" cy="1371600"/>
+          <a:ext cx="4297680" cy="1097280"/>
         </p:xfrm>
         <a:graphic>
           <a:graphicData uri="http://schemas.openxmlformats.org/drawingml/2006/table">
@@ -18194,217 +18194,6 @@
                           <a:ea typeface="Segoe UI" pitchFamily="34" charset="-122"/>
                           <a:cs typeface="Segoe UI" pitchFamily="34" charset="-120"/>
                         </a:rPr>
-                        <a:t>Regressão logística</a:t>
-                      </a:r>
-                      <a:endParaRPr lang="en-US" sz="1050" dirty="0">
-                        <a:latin typeface="Segoe UI" charset="0"/>
-                        <a:ea typeface="Segoe UI" charset="0"/>
-                        <a:cs typeface="Segoe UI" charset="0"/>
-                      </a:endParaRPr>
-                    </a:p>
-                  </a:txBody>
-                  <a:tcPr marL="0" marR="0" marT="0" marB="0" anchor="ctr">
-                    <a:lnL w="6350" cap="flat" cmpd="sng" algn="ctr">
-                      <a:solidFill>
-                        <a:srgbClr val="1E2B57"/>
-                      </a:solidFill>
-                      <a:prstDash val="solid"/>
-                      <a:round/>
-                      <a:headEnd type="none" w="med" len="med"/>
-                      <a:tailEnd type="none" w="med" len="med"/>
-                    </a:lnL>
-                    <a:lnR w="6350" cap="flat" cmpd="sng" algn="ctr">
-                      <a:solidFill>
-                        <a:srgbClr val="1E2B57"/>
-                      </a:solidFill>
-                      <a:prstDash val="solid"/>
-                      <a:round/>
-                      <a:headEnd type="none" w="med" len="med"/>
-                      <a:tailEnd type="none" w="med" len="med"/>
-                    </a:lnR>
-                    <a:lnT w="6350" cap="flat" cmpd="sng" algn="ctr">
-                      <a:solidFill>
-                        <a:srgbClr val="1E2B57"/>
-                      </a:solidFill>
-                      <a:prstDash val="solid"/>
-                      <a:round/>
-                      <a:headEnd type="none" w="med" len="med"/>
-                      <a:tailEnd type="none" w="med" len="med"/>
-                    </a:lnT>
-                    <a:lnB w="6350" cap="flat" cmpd="sng" algn="ctr">
-                      <a:solidFill>
-                        <a:srgbClr val="1E2B57"/>
-                      </a:solidFill>
-                      <a:prstDash val="solid"/>
-                      <a:round/>
-                      <a:headEnd type="none" w="med" len="med"/>
-                      <a:tailEnd type="none" w="med" len="med"/>
-                    </a:lnB>
-                    <a:solidFill>
-                      <a:srgbClr val="0E1733"/>
-                    </a:solidFill>
-                  </a:tcPr>
-                </a:tc>
-                <a:tc>
-                  <a:txBody>
-                    <a:bodyPr/>
-                    <a:lstStyle/>
-                    <a:p>
-                      <a:pPr marL="0" indent="0" algn="r">
-                        <a:buNone/>
-                      </a:pPr>
-                      <a:r>
-                        <a:rPr lang="en-US" sz="1050" dirty="0">
-                          <a:solidFill>
-                            <a:srgbClr val="A8B8D9"/>
-                          </a:solidFill>
-                          <a:latin typeface="Segoe UI" pitchFamily="34" charset="0"/>
-                          <a:ea typeface="Segoe UI" pitchFamily="34" charset="-122"/>
-                          <a:cs typeface="Segoe UI" pitchFamily="34" charset="-120"/>
-                        </a:rPr>
-                        <a:t>96,79%</a:t>
-                      </a:r>
-                      <a:endParaRPr lang="en-US" sz="1050" dirty="0">
-                        <a:latin typeface="Segoe UI" charset="0"/>
-                        <a:ea typeface="Segoe UI" charset="0"/>
-                        <a:cs typeface="Segoe UI" charset="0"/>
-                      </a:endParaRPr>
-                    </a:p>
-                  </a:txBody>
-                  <a:tcPr marL="0" marR="0" marT="0" marB="0" anchor="ctr">
-                    <a:lnL w="6350" cap="flat" cmpd="sng" algn="ctr">
-                      <a:solidFill>
-                        <a:srgbClr val="1E2B57"/>
-                      </a:solidFill>
-                      <a:prstDash val="solid"/>
-                      <a:round/>
-                      <a:headEnd type="none" w="med" len="med"/>
-                      <a:tailEnd type="none" w="med" len="med"/>
-                    </a:lnL>
-                    <a:lnR w="6350" cap="flat" cmpd="sng" algn="ctr">
-                      <a:solidFill>
-                        <a:srgbClr val="1E2B57"/>
-                      </a:solidFill>
-                      <a:prstDash val="solid"/>
-                      <a:round/>
-                      <a:headEnd type="none" w="med" len="med"/>
-                      <a:tailEnd type="none" w="med" len="med"/>
-                    </a:lnR>
-                    <a:lnT w="6350" cap="flat" cmpd="sng" algn="ctr">
-                      <a:solidFill>
-                        <a:srgbClr val="1E2B57"/>
-                      </a:solidFill>
-                      <a:prstDash val="solid"/>
-                      <a:round/>
-                      <a:headEnd type="none" w="med" len="med"/>
-                      <a:tailEnd type="none" w="med" len="med"/>
-                    </a:lnT>
-                    <a:lnB w="6350" cap="flat" cmpd="sng" algn="ctr">
-                      <a:solidFill>
-                        <a:srgbClr val="1E2B57"/>
-                      </a:solidFill>
-                      <a:prstDash val="solid"/>
-                      <a:round/>
-                      <a:headEnd type="none" w="med" len="med"/>
-                      <a:tailEnd type="none" w="med" len="med"/>
-                    </a:lnB>
-                    <a:solidFill>
-                      <a:srgbClr val="0E1733"/>
-                    </a:solidFill>
-                  </a:tcPr>
-                </a:tc>
-                <a:tc>
-                  <a:txBody>
-                    <a:bodyPr/>
-                    <a:lstStyle/>
-                    <a:p>
-                      <a:pPr marL="0" indent="0" algn="r">
-                        <a:buNone/>
-                      </a:pPr>
-                      <a:r>
-                        <a:rPr lang="en-US" sz="1050" dirty="0">
-                          <a:solidFill>
-                            <a:srgbClr val="A8B8D9"/>
-                          </a:solidFill>
-                          <a:latin typeface="Segoe UI" pitchFamily="34" charset="0"/>
-                          <a:ea typeface="Segoe UI" pitchFamily="34" charset="-122"/>
-                          <a:cs typeface="Segoe UI" pitchFamily="34" charset="-120"/>
-                        </a:rPr>
-                        <a:t>0,832</a:t>
-                      </a:r>
-                      <a:endParaRPr lang="en-US" sz="1050" dirty="0">
-                        <a:latin typeface="Segoe UI" charset="0"/>
-                        <a:ea typeface="Segoe UI" charset="0"/>
-                        <a:cs typeface="Segoe UI" charset="0"/>
-                      </a:endParaRPr>
-                    </a:p>
-                  </a:txBody>
-                  <a:tcPr marL="0" marR="0" marT="0" marB="0" anchor="ctr">
-                    <a:lnL w="6350" cap="flat" cmpd="sng" algn="ctr">
-                      <a:solidFill>
-                        <a:srgbClr val="1E2B57"/>
-                      </a:solidFill>
-                      <a:prstDash val="solid"/>
-                      <a:round/>
-                      <a:headEnd type="none" w="med" len="med"/>
-                      <a:tailEnd type="none" w="med" len="med"/>
-                    </a:lnL>
-                    <a:lnR w="6350" cap="flat" cmpd="sng" algn="ctr">
-                      <a:solidFill>
-                        <a:srgbClr val="1E2B57"/>
-                      </a:solidFill>
-                      <a:prstDash val="solid"/>
-                      <a:round/>
-                      <a:headEnd type="none" w="med" len="med"/>
-                      <a:tailEnd type="none" w="med" len="med"/>
-                    </a:lnR>
-                    <a:lnT w="6350" cap="flat" cmpd="sng" algn="ctr">
-                      <a:solidFill>
-                        <a:srgbClr val="1E2B57"/>
-                      </a:solidFill>
-                      <a:prstDash val="solid"/>
-                      <a:round/>
-                      <a:headEnd type="none" w="med" len="med"/>
-                      <a:tailEnd type="none" w="med" len="med"/>
-                    </a:lnT>
-                    <a:lnB w="6350" cap="flat" cmpd="sng" algn="ctr">
-                      <a:solidFill>
-                        <a:srgbClr val="1E2B57"/>
-                      </a:solidFill>
-                      <a:prstDash val="solid"/>
-                      <a:round/>
-                      <a:headEnd type="none" w="med" len="med"/>
-                      <a:tailEnd type="none" w="med" len="med"/>
-                    </a:lnB>
-                    <a:solidFill>
-                      <a:srgbClr val="0E1733"/>
-                    </a:solidFill>
-                  </a:tcPr>
-                </a:tc>
-                <a:extLst>
-                  <a:ext uri="{0D108BD9-81ED-4DB2-BD59-A6C34878D82A}">
-                    <a16:rowId xmlns:a16="http://schemas.microsoft.com/office/drawing/2014/main" val="10002"/>
-                  </a:ext>
-                </a:extLst>
-              </a:tr>
-              <a:tr h="274320">
-                <a:tc>
-                  <a:txBody>
-                    <a:bodyPr/>
-                    <a:lstStyle/>
-                    <a:p>
-                      <a:pPr marL="0" indent="0" algn="l">
-                        <a:buNone/>
-                      </a:pPr>
-                      <a:r>
-                        <a:rPr lang="en-US" sz="1050" dirty="0">
-                          <a:solidFill>
-                            <a:srgbClr val="A8B8D9"/>
-                          </a:solidFill>
-                          <a:latin typeface="Segoe UI" pitchFamily="34" charset="0"/>
-                          <a:ea typeface="Segoe UI" pitchFamily="34" charset="-122"/>
-                          <a:cs typeface="Segoe UI" pitchFamily="34" charset="-120"/>
-                        </a:rPr>
                         <a:t>MLP hard-code</a:t>
                       </a:r>
                       <a:endParaRPr lang="en-US" sz="1050" dirty="0">

</xml_diff>